<commit_message>
move generated files to target
</commit_message>
<xml_diff>
--- a/docs/intro.pptx
+++ b/docs/intro.pptx
@@ -3338,7 +3338,12 @@
             <p:ph type="ctrTitle"/>
           </p:nvPr>
         </p:nvSpPr>
-        <p:spPr/>
+        <p:spPr>
+          <a:xfrm>
+            <a:off x="1524000" y="1122363"/>
+            <a:ext cx="10363200" cy="2387600"/>
+          </a:xfrm>
+        </p:spPr>
         <p:txBody>
           <a:bodyPr>
             <a:normAutofit fontScale="90000"/>
@@ -3347,7 +3352,7 @@
           <a:p>
             <a:r>
               <a:rPr lang="en-US" dirty="0"/>
-              <a:t>Nine Ways to Inherit in Rust</a:t>
+              <a:t>Nine Ways to do Inheritance in Rust,</a:t>
             </a:r>
             <a:br>
               <a:rPr lang="en-US" dirty="0"/>
@@ -3406,15 +3411,22 @@
               <a:t>CarlKCarlK</a:t>
             </a:r>
             <a:r>
-              <a:rPr lang="en-US" dirty="0">
+              <a:rPr lang="en-US">
                 <a:solidFill>
                   <a:schemeClr val="bg1">
                     <a:lumMod val="50000"/>
                   </a:schemeClr>
                 </a:solidFill>
               </a:rPr>
-              <a:t>/rust-inherit</a:t>
-            </a:r>
+              <a:t>/inherit</a:t>
+            </a:r>
+            <a:endParaRPr lang="en-US" dirty="0">
+              <a:solidFill>
+                <a:schemeClr val="bg1">
+                  <a:lumMod val="50000"/>
+                </a:schemeClr>
+              </a:solidFill>
+            </a:endParaRPr>
           </a:p>
           <a:p>
             <a:endParaRPr lang="en-US" dirty="0"/>
@@ -3555,6 +3567,13 @@
             <a:r>
               <a:rPr lang="en-US" dirty="0"/>
               <a:t>inspired by real code</a:t>
+            </a:r>
+          </a:p>
+          <a:p>
+            <a:pPr lvl="1"/>
+            <a:r>
+              <a:rPr lang="en-US" dirty="0"/>
+              <a:t>discussion welcome</a:t>
             </a:r>
           </a:p>
           <a:p>

</xml_diff>